<commit_message>
Brand: true Ignite vector from the site, Packaging rebuilt from the Canva PDF, TM matched to the Talent lockup
</commit_message>
<xml_diff>
--- a/brand/flex-client-proposal.pptx
+++ b/brand/flex-client-proposal.pptx
@@ -113,33 +113,33 @@
   <p:extLst>
     <p:ext uri="{521415D9-36F7-43E2-AB2F-B90AF26B5E84}">
       <p14:sectionLst xmlns:p14="http://schemas.microsoft.com/office/powerpoint/2010/main">
-        <p14:section name="Cover" id="{2a81bb4c-1cd3-8dc2-3650-2cdf4bafb86c}">
+        <p14:section name="Cover" id="{485e423a-9c2e-c2ff-4021-7182a95d1fc0}">
           <p14:sldIdLst>
             <p14:sldId id="256"/>
           </p14:sldIdLst>
         </p14:section>
-        <p14:section name="Understanding" id="{76fbd8ca-c828-a1e5-4537-690766ae93a1}">
+        <p14:section name="Understanding" id="{038abd4c-188e-8c39-a95a-5950264abd1b}">
           <p14:sldIdLst>
             <p14:sldId id="257"/>
             <p14:sldId id="258"/>
           </p14:sldIdLst>
         </p14:section>
-        <p14:section name="Approach" id="{daa77bf3-1493-72a3-a66a-9757d8621037}">
+        <p14:section name="Approach" id="{7bf451a0-cfc5-6e92-c6c1-46a79674986a}">
           <p14:sldIdLst>
             <p14:sldId id="259"/>
           </p14:sldIdLst>
         </p14:section>
-        <p14:section name="Proof" id="{bd39e6d1-5eea-049a-75c6-bbf384224dd1}">
+        <p14:section name="Proof" id="{42195672-ee65-7842-96cf-a530545ee53b}">
           <p14:sldIdLst>
             <p14:sldId id="260"/>
           </p14:sldIdLst>
         </p14:section>
-        <p14:section name="Commercials" id="{60c50477-c8cd-b8b5-1546-6fa29d10c19c}">
+        <p14:section name="Commercials" id="{91347512-2801-1c4a-47f6-dd2e66fc6cef}">
           <p14:sldIdLst>
             <p14:sldId id="261"/>
           </p14:sldIdLst>
         </p14:section>
-        <p14:section name="Close" id="{e83f286e-aabc-cf9a-230f-decc253c2e7a}">
+        <p14:section name="Close" id="{1256ed57-7541-6946-3d5b-1a65fd99bdca}">
           <p14:sldIdLst>
             <p14:sldId id="262"/>
           </p14:sldIdLst>
@@ -1189,7 +1189,7 @@
         <p:spPr>
           <a:xfrm>
             <a:off x="658368" y="548640"/>
-            <a:ext cx="2292401" cy="726948"/>
+            <a:ext cx="2104949" cy="726948"/>
           </a:xfrm>
           <a:prstGeom prst="rect">
             <a:avLst/>
@@ -1460,7 +1460,7 @@
         <p:spPr>
           <a:xfrm>
             <a:off x="10332720" y="5852160"/>
-            <a:ext cx="1294790" cy="410566"/>
+            <a:ext cx="1188720" cy="410566"/>
           </a:xfrm>
           <a:prstGeom prst="rect">
             <a:avLst/>
@@ -1614,7 +1614,7 @@
         <p:spPr>
           <a:xfrm>
             <a:off x="10716768" y="6053328"/>
-            <a:ext cx="946404" cy="299923"/>
+            <a:ext cx="868680" cy="299923"/>
           </a:xfrm>
           <a:prstGeom prst="rect">
             <a:avLst/>
@@ -1748,7 +1748,7 @@
         <p:spPr>
           <a:xfrm>
             <a:off x="10716768" y="6053328"/>
-            <a:ext cx="946404" cy="299923"/>
+            <a:ext cx="868680" cy="299923"/>
           </a:xfrm>
           <a:prstGeom prst="rect">
             <a:avLst/>
@@ -1921,7 +1921,7 @@
         <p:spPr>
           <a:xfrm>
             <a:off x="10332720" y="5760720"/>
-            <a:ext cx="1294790" cy="410566"/>
+            <a:ext cx="1188720" cy="410566"/>
           </a:xfrm>
           <a:prstGeom prst="rect">
             <a:avLst/>

</xml_diff>